<commit_message>
fix(sharing): P27 layout — keep F7 inside slide; render as full-width banner
Previously F7 was hard-coded to position (4.7", 6.92") which pushed its
2.30"-tall card down to y=9.22" — well beyond the 7.5" slide bottom.

Re-architect the slide:
- F1–F6 use a cleaner 2×3 grid with smaller cards (1.95" tall)
- F7 (cross-cut '可复现评测协议' — semantically a measurement layer,
  not a system feature) is rendered as a full-width banner card at the
  bottom of the slide
- F7 banner now sits at top=6.29" / bot=7.07", inside the slide frame
- Description on F7 is rephrased to highlight its '横切度量层' role:
  '把前 6 个特征真正落到工程的前提'

Visual hierarchy now reads: 6 system features (grid) + 1 cross-cut
measurement layer (banner) — matches the actual semantics of F1–F7.

Co-authored-by: Yulong <yl.w@outlook.com>
</commit_message>
<xml_diff>
--- a/docs/sharing/ai-native-insight-deck.pptx
+++ b/docs/sharing/ai-native-insight-deck.pptx
@@ -31207,7 +31207,7 @@
         <p:spPr>
           <a:xfrm>
             <a:off x="548640" y="1828800"/>
-            <a:ext cx="3657600" cy="2103120"/>
+            <a:ext cx="3657600" cy="1783080"/>
           </a:xfrm>
           <a:prstGeom prst="roundRect">
             <a:avLst>
@@ -31252,7 +31252,7 @@
         <p:spPr>
           <a:xfrm>
             <a:off x="548640" y="1828800"/>
-            <a:ext cx="128016" cy="2103120"/>
+            <a:ext cx="128016" cy="1783080"/>
           </a:xfrm>
           <a:prstGeom prst="rect">
             <a:avLst/>
@@ -31294,8 +31294,8 @@
         </p:nvSpPr>
         <p:spPr>
           <a:xfrm>
-            <a:off x="822960" y="1938528"/>
-            <a:ext cx="777240" cy="365760"/>
+            <a:off x="822960" y="1920240"/>
+            <a:ext cx="777240" cy="329184"/>
           </a:xfrm>
           <a:prstGeom prst="rect">
             <a:avLst/>
@@ -31329,8 +31329,8 @@
         </p:nvSpPr>
         <p:spPr>
           <a:xfrm>
-            <a:off x="1554480" y="1947672"/>
-            <a:ext cx="2560320" cy="365760"/>
+            <a:off x="1554480" y="1929384"/>
+            <a:ext cx="2560320" cy="329184"/>
           </a:xfrm>
           <a:prstGeom prst="rect">
             <a:avLst/>
@@ -31364,8 +31364,8 @@
         </p:nvSpPr>
         <p:spPr>
           <a:xfrm>
-            <a:off x="822960" y="2377440"/>
-            <a:ext cx="3291840" cy="365760"/>
+            <a:off x="822960" y="2331720"/>
+            <a:ext cx="3291840" cy="292608"/>
           </a:xfrm>
           <a:prstGeom prst="rect">
             <a:avLst/>
@@ -31380,42 +31380,42 @@
           <a:p>
             <a:pPr algn="l"/>
             <a:r>
+              <a:rPr sz="1050" b="0" i="0">
+                <a:solidFill>
+                  <a:srgbClr val="F2C55C"/>
+                </a:solidFill>
+                <a:latin typeface="Consolas"/>
+              </a:rPr>
+              <a:t>T4 · T5 / H1</a:t>
+            </a:r>
+          </a:p>
+        </p:txBody>
+      </p:sp>
+      <p:sp>
+        <p:nvSpPr>
+          <p:cNvPr id="13" name="TextBox 12"/>
+          <p:cNvSpPr txBox="1"/>
+          <p:nvPr/>
+        </p:nvSpPr>
+        <p:spPr>
+          <a:xfrm>
+            <a:off x="822960" y="2670048"/>
+            <a:ext cx="3291840" cy="868680"/>
+          </a:xfrm>
+          <a:prstGeom prst="rect">
+            <a:avLst/>
+          </a:prstGeom>
+          <a:noFill/>
+        </p:spPr>
+        <p:txBody>
+          <a:bodyPr wrap="square" lIns="0" rIns="0" tIns="0" bIns="0" anchor="t">
+            <a:spAutoFit/>
+          </a:bodyPr>
+          <a:lstStyle/>
+          <a:p>
+            <a:pPr algn="l"/>
+            <a:r>
               <a:rPr sz="1100" b="0" i="0">
-                <a:solidFill>
-                  <a:srgbClr val="F2C55C"/>
-                </a:solidFill>
-                <a:latin typeface="Consolas"/>
-              </a:rPr>
-              <a:t>T4 · T5 / H1</a:t>
-            </a:r>
-          </a:p>
-        </p:txBody>
-      </p:sp>
-      <p:sp>
-        <p:nvSpPr>
-          <p:cNvPr id="13" name="TextBox 12"/>
-          <p:cNvSpPr txBox="1"/>
-          <p:nvPr/>
-        </p:nvSpPr>
-        <p:spPr>
-          <a:xfrm>
-            <a:off x="822960" y="2743200"/>
-            <a:ext cx="3291840" cy="1143000"/>
-          </a:xfrm>
-          <a:prstGeom prst="rect">
-            <a:avLst/>
-          </a:prstGeom>
-          <a:noFill/>
-        </p:spPr>
-        <p:txBody>
-          <a:bodyPr wrap="square" lIns="0" rIns="0" tIns="0" bIns="0" anchor="t">
-            <a:spAutoFit/>
-          </a:bodyPr>
-          <a:lstStyle/>
-          <a:p>
-            <a:pPr algn="l"/>
-            <a:r>
-              <a:rPr sz="1150" b="0" i="0">
                 <a:solidFill>
                   <a:srgbClr val="9FB5C9"/>
                 </a:solidFill>
@@ -31435,7 +31435,7 @@
         <p:spPr>
           <a:xfrm>
             <a:off x="4297680" y="1828800"/>
-            <a:ext cx="3657600" cy="2103120"/>
+            <a:ext cx="3657600" cy="1783080"/>
           </a:xfrm>
           <a:prstGeom prst="roundRect">
             <a:avLst>
@@ -31480,7 +31480,7 @@
         <p:spPr>
           <a:xfrm>
             <a:off x="4297680" y="1828800"/>
-            <a:ext cx="128016" cy="2103120"/>
+            <a:ext cx="128016" cy="1783080"/>
           </a:xfrm>
           <a:prstGeom prst="rect">
             <a:avLst/>
@@ -31522,8 +31522,8 @@
         </p:nvSpPr>
         <p:spPr>
           <a:xfrm>
-            <a:off x="4572000" y="1938528"/>
-            <a:ext cx="777240" cy="365760"/>
+            <a:off x="4572000" y="1920240"/>
+            <a:ext cx="777240" cy="329184"/>
           </a:xfrm>
           <a:prstGeom prst="rect">
             <a:avLst/>
@@ -31557,8 +31557,8 @@
         </p:nvSpPr>
         <p:spPr>
           <a:xfrm>
-            <a:off x="5303520" y="1947672"/>
-            <a:ext cx="2560320" cy="365760"/>
+            <a:off x="5303520" y="1929384"/>
+            <a:ext cx="2560320" cy="329184"/>
           </a:xfrm>
           <a:prstGeom prst="rect">
             <a:avLst/>
@@ -31592,8 +31592,8 @@
         </p:nvSpPr>
         <p:spPr>
           <a:xfrm>
-            <a:off x="4572000" y="2377440"/>
-            <a:ext cx="3291840" cy="365760"/>
+            <a:off x="4572000" y="2331720"/>
+            <a:ext cx="3291840" cy="292608"/>
           </a:xfrm>
           <a:prstGeom prst="rect">
             <a:avLst/>
@@ -31608,42 +31608,42 @@
           <a:p>
             <a:pPr algn="l"/>
             <a:r>
+              <a:rPr sz="1050" b="0" i="0">
+                <a:solidFill>
+                  <a:srgbClr val="F2C55C"/>
+                </a:solidFill>
+                <a:latin typeface="Consolas"/>
+              </a:rPr>
+              <a:t>T2 / H2 · H6</a:t>
+            </a:r>
+          </a:p>
+        </p:txBody>
+      </p:sp>
+      <p:sp>
+        <p:nvSpPr>
+          <p:cNvPr id="19" name="TextBox 18"/>
+          <p:cNvSpPr txBox="1"/>
+          <p:nvPr/>
+        </p:nvSpPr>
+        <p:spPr>
+          <a:xfrm>
+            <a:off x="4572000" y="2670048"/>
+            <a:ext cx="3291840" cy="868680"/>
+          </a:xfrm>
+          <a:prstGeom prst="rect">
+            <a:avLst/>
+          </a:prstGeom>
+          <a:noFill/>
+        </p:spPr>
+        <p:txBody>
+          <a:bodyPr wrap="square" lIns="0" rIns="0" tIns="0" bIns="0" anchor="t">
+            <a:spAutoFit/>
+          </a:bodyPr>
+          <a:lstStyle/>
+          <a:p>
+            <a:pPr algn="l"/>
+            <a:r>
               <a:rPr sz="1100" b="0" i="0">
-                <a:solidFill>
-                  <a:srgbClr val="F2C55C"/>
-                </a:solidFill>
-                <a:latin typeface="Consolas"/>
-              </a:rPr>
-              <a:t>T2 / H2 · H6</a:t>
-            </a:r>
-          </a:p>
-        </p:txBody>
-      </p:sp>
-      <p:sp>
-        <p:nvSpPr>
-          <p:cNvPr id="19" name="TextBox 18"/>
-          <p:cNvSpPr txBox="1"/>
-          <p:nvPr/>
-        </p:nvSpPr>
-        <p:spPr>
-          <a:xfrm>
-            <a:off x="4572000" y="2743200"/>
-            <a:ext cx="3291840" cy="1143000"/>
-          </a:xfrm>
-          <a:prstGeom prst="rect">
-            <a:avLst/>
-          </a:prstGeom>
-          <a:noFill/>
-        </p:spPr>
-        <p:txBody>
-          <a:bodyPr wrap="square" lIns="0" rIns="0" tIns="0" bIns="0" anchor="t">
-            <a:spAutoFit/>
-          </a:bodyPr>
-          <a:lstStyle/>
-          <a:p>
-            <a:pPr algn="l"/>
-            <a:r>
-              <a:rPr sz="1150" b="0" i="0">
                 <a:solidFill>
                   <a:srgbClr val="9FB5C9"/>
                 </a:solidFill>
@@ -31663,7 +31663,7 @@
         <p:spPr>
           <a:xfrm>
             <a:off x="8046720" y="1828800"/>
-            <a:ext cx="3657600" cy="2103120"/>
+            <a:ext cx="3657600" cy="1783080"/>
           </a:xfrm>
           <a:prstGeom prst="roundRect">
             <a:avLst>
@@ -31708,7 +31708,7 @@
         <p:spPr>
           <a:xfrm>
             <a:off x="8046720" y="1828800"/>
-            <a:ext cx="128016" cy="2103120"/>
+            <a:ext cx="128016" cy="1783080"/>
           </a:xfrm>
           <a:prstGeom prst="rect">
             <a:avLst/>
@@ -31750,8 +31750,8 @@
         </p:nvSpPr>
         <p:spPr>
           <a:xfrm>
-            <a:off x="8321040" y="1938528"/>
-            <a:ext cx="777240" cy="365760"/>
+            <a:off x="8321040" y="1920240"/>
+            <a:ext cx="777240" cy="329184"/>
           </a:xfrm>
           <a:prstGeom prst="rect">
             <a:avLst/>
@@ -31785,8 +31785,8 @@
         </p:nvSpPr>
         <p:spPr>
           <a:xfrm>
-            <a:off x="9052560" y="1947672"/>
-            <a:ext cx="2560320" cy="365760"/>
+            <a:off x="9052560" y="1929384"/>
+            <a:ext cx="2560320" cy="329184"/>
           </a:xfrm>
           <a:prstGeom prst="rect">
             <a:avLst/>
@@ -31820,8 +31820,8 @@
         </p:nvSpPr>
         <p:spPr>
           <a:xfrm>
-            <a:off x="8321040" y="2377440"/>
-            <a:ext cx="3291840" cy="365760"/>
+            <a:off x="8321040" y="2331720"/>
+            <a:ext cx="3291840" cy="292608"/>
           </a:xfrm>
           <a:prstGeom prst="rect">
             <a:avLst/>
@@ -31836,42 +31836,42 @@
           <a:p>
             <a:pPr algn="l"/>
             <a:r>
+              <a:rPr sz="1050" b="0" i="0">
+                <a:solidFill>
+                  <a:srgbClr val="F2C55C"/>
+                </a:solidFill>
+                <a:latin typeface="Consolas"/>
+              </a:rPr>
+              <a:t>T2 · T4 / H2 · H7</a:t>
+            </a:r>
+          </a:p>
+        </p:txBody>
+      </p:sp>
+      <p:sp>
+        <p:nvSpPr>
+          <p:cNvPr id="25" name="TextBox 24"/>
+          <p:cNvSpPr txBox="1"/>
+          <p:nvPr/>
+        </p:nvSpPr>
+        <p:spPr>
+          <a:xfrm>
+            <a:off x="8321040" y="2670048"/>
+            <a:ext cx="3291840" cy="868680"/>
+          </a:xfrm>
+          <a:prstGeom prst="rect">
+            <a:avLst/>
+          </a:prstGeom>
+          <a:noFill/>
+        </p:spPr>
+        <p:txBody>
+          <a:bodyPr wrap="square" lIns="0" rIns="0" tIns="0" bIns="0" anchor="t">
+            <a:spAutoFit/>
+          </a:bodyPr>
+          <a:lstStyle/>
+          <a:p>
+            <a:pPr algn="l"/>
+            <a:r>
               <a:rPr sz="1100" b="0" i="0">
-                <a:solidFill>
-                  <a:srgbClr val="F2C55C"/>
-                </a:solidFill>
-                <a:latin typeface="Consolas"/>
-              </a:rPr>
-              <a:t>T2 · T4 / H2 · H7</a:t>
-            </a:r>
-          </a:p>
-        </p:txBody>
-      </p:sp>
-      <p:sp>
-        <p:nvSpPr>
-          <p:cNvPr id="25" name="TextBox 24"/>
-          <p:cNvSpPr txBox="1"/>
-          <p:nvPr/>
-        </p:nvSpPr>
-        <p:spPr>
-          <a:xfrm>
-            <a:off x="8321040" y="2743200"/>
-            <a:ext cx="3291840" cy="1143000"/>
-          </a:xfrm>
-          <a:prstGeom prst="rect">
-            <a:avLst/>
-          </a:prstGeom>
-          <a:noFill/>
-        </p:spPr>
-        <p:txBody>
-          <a:bodyPr wrap="square" lIns="0" rIns="0" tIns="0" bIns="0" anchor="t">
-            <a:spAutoFit/>
-          </a:bodyPr>
-          <a:lstStyle/>
-          <a:p>
-            <a:pPr algn="l"/>
-            <a:r>
-              <a:rPr sz="1150" b="0" i="0">
                 <a:solidFill>
                   <a:srgbClr val="9FB5C9"/>
                 </a:solidFill>
@@ -31890,8 +31890,8 @@
         </p:nvSpPr>
         <p:spPr>
           <a:xfrm>
-            <a:off x="548640" y="4078224"/>
-            <a:ext cx="3657600" cy="2103120"/>
+            <a:off x="548640" y="3730752"/>
+            <a:ext cx="3657600" cy="1783080"/>
           </a:xfrm>
           <a:prstGeom prst="roundRect">
             <a:avLst>
@@ -31935,8 +31935,8 @@
         </p:nvSpPr>
         <p:spPr>
           <a:xfrm>
-            <a:off x="548640" y="4078224"/>
-            <a:ext cx="128016" cy="2103120"/>
+            <a:off x="548640" y="3730752"/>
+            <a:ext cx="128016" cy="1783080"/>
           </a:xfrm>
           <a:prstGeom prst="rect">
             <a:avLst/>
@@ -31978,8 +31978,8 @@
         </p:nvSpPr>
         <p:spPr>
           <a:xfrm>
-            <a:off x="822960" y="4187952"/>
-            <a:ext cx="777240" cy="365760"/>
+            <a:off x="822960" y="3822192"/>
+            <a:ext cx="777240" cy="329184"/>
           </a:xfrm>
           <a:prstGeom prst="rect">
             <a:avLst/>
@@ -32013,8 +32013,8 @@
         </p:nvSpPr>
         <p:spPr>
           <a:xfrm>
-            <a:off x="1554480" y="4197096"/>
-            <a:ext cx="2560320" cy="365760"/>
+            <a:off x="1554480" y="3831336"/>
+            <a:ext cx="2560320" cy="329184"/>
           </a:xfrm>
           <a:prstGeom prst="rect">
             <a:avLst/>
@@ -32048,8 +32048,8 @@
         </p:nvSpPr>
         <p:spPr>
           <a:xfrm>
-            <a:off x="822960" y="4626864"/>
-            <a:ext cx="3291840" cy="365760"/>
+            <a:off x="822960" y="4233672"/>
+            <a:ext cx="3291840" cy="292608"/>
           </a:xfrm>
           <a:prstGeom prst="rect">
             <a:avLst/>
@@ -32064,42 +32064,42 @@
           <a:p>
             <a:pPr algn="l"/>
             <a:r>
+              <a:rPr sz="1050" b="0" i="0">
+                <a:solidFill>
+                  <a:srgbClr val="F2C55C"/>
+                </a:solidFill>
+                <a:latin typeface="Consolas"/>
+              </a:rPr>
+              <a:t>T3 / H3 · H4</a:t>
+            </a:r>
+          </a:p>
+        </p:txBody>
+      </p:sp>
+      <p:sp>
+        <p:nvSpPr>
+          <p:cNvPr id="31" name="TextBox 30"/>
+          <p:cNvSpPr txBox="1"/>
+          <p:nvPr/>
+        </p:nvSpPr>
+        <p:spPr>
+          <a:xfrm>
+            <a:off x="822960" y="4572000"/>
+            <a:ext cx="3291840" cy="868680"/>
+          </a:xfrm>
+          <a:prstGeom prst="rect">
+            <a:avLst/>
+          </a:prstGeom>
+          <a:noFill/>
+        </p:spPr>
+        <p:txBody>
+          <a:bodyPr wrap="square" lIns="0" rIns="0" tIns="0" bIns="0" anchor="t">
+            <a:spAutoFit/>
+          </a:bodyPr>
+          <a:lstStyle/>
+          <a:p>
+            <a:pPr algn="l"/>
+            <a:r>
               <a:rPr sz="1100" b="0" i="0">
-                <a:solidFill>
-                  <a:srgbClr val="F2C55C"/>
-                </a:solidFill>
-                <a:latin typeface="Consolas"/>
-              </a:rPr>
-              <a:t>T3 / H3 · H4</a:t>
-            </a:r>
-          </a:p>
-        </p:txBody>
-      </p:sp>
-      <p:sp>
-        <p:nvSpPr>
-          <p:cNvPr id="31" name="TextBox 30"/>
-          <p:cNvSpPr txBox="1"/>
-          <p:nvPr/>
-        </p:nvSpPr>
-        <p:spPr>
-          <a:xfrm>
-            <a:off x="822960" y="4992624"/>
-            <a:ext cx="3291840" cy="1143000"/>
-          </a:xfrm>
-          <a:prstGeom prst="rect">
-            <a:avLst/>
-          </a:prstGeom>
-          <a:noFill/>
-        </p:spPr>
-        <p:txBody>
-          <a:bodyPr wrap="square" lIns="0" rIns="0" tIns="0" bIns="0" anchor="t">
-            <a:spAutoFit/>
-          </a:bodyPr>
-          <a:lstStyle/>
-          <a:p>
-            <a:pPr algn="l"/>
-            <a:r>
-              <a:rPr sz="1150" b="0" i="0">
                 <a:solidFill>
                   <a:srgbClr val="9FB5C9"/>
                 </a:solidFill>
@@ -32118,8 +32118,8 @@
         </p:nvSpPr>
         <p:spPr>
           <a:xfrm>
-            <a:off x="4297680" y="4078224"/>
-            <a:ext cx="3657600" cy="2103120"/>
+            <a:off x="4297680" y="3730752"/>
+            <a:ext cx="3657600" cy="1783080"/>
           </a:xfrm>
           <a:prstGeom prst="roundRect">
             <a:avLst>
@@ -32163,8 +32163,8 @@
         </p:nvSpPr>
         <p:spPr>
           <a:xfrm>
-            <a:off x="4297680" y="4078224"/>
-            <a:ext cx="128016" cy="2103120"/>
+            <a:off x="4297680" y="3730752"/>
+            <a:ext cx="128016" cy="1783080"/>
           </a:xfrm>
           <a:prstGeom prst="rect">
             <a:avLst/>
@@ -32206,8 +32206,8 @@
         </p:nvSpPr>
         <p:spPr>
           <a:xfrm>
-            <a:off x="4572000" y="4187952"/>
-            <a:ext cx="777240" cy="365760"/>
+            <a:off x="4572000" y="3822192"/>
+            <a:ext cx="777240" cy="329184"/>
           </a:xfrm>
           <a:prstGeom prst="rect">
             <a:avLst/>
@@ -32241,8 +32241,8 @@
         </p:nvSpPr>
         <p:spPr>
           <a:xfrm>
-            <a:off x="5303520" y="4197096"/>
-            <a:ext cx="2560320" cy="365760"/>
+            <a:off x="5303520" y="3831336"/>
+            <a:ext cx="2560320" cy="329184"/>
           </a:xfrm>
           <a:prstGeom prst="rect">
             <a:avLst/>
@@ -32276,8 +32276,8 @@
         </p:nvSpPr>
         <p:spPr>
           <a:xfrm>
-            <a:off x="4572000" y="4626864"/>
-            <a:ext cx="3291840" cy="365760"/>
+            <a:off x="4572000" y="4233672"/>
+            <a:ext cx="3291840" cy="292608"/>
           </a:xfrm>
           <a:prstGeom prst="rect">
             <a:avLst/>
@@ -32292,42 +32292,42 @@
           <a:p>
             <a:pPr algn="l"/>
             <a:r>
+              <a:rPr sz="1050" b="0" i="0">
+                <a:solidFill>
+                  <a:srgbClr val="F2C55C"/>
+                </a:solidFill>
+                <a:latin typeface="Consolas"/>
+              </a:rPr>
+              <a:t>T5 / H1 · H8</a:t>
+            </a:r>
+          </a:p>
+        </p:txBody>
+      </p:sp>
+      <p:sp>
+        <p:nvSpPr>
+          <p:cNvPr id="37" name="TextBox 36"/>
+          <p:cNvSpPr txBox="1"/>
+          <p:nvPr/>
+        </p:nvSpPr>
+        <p:spPr>
+          <a:xfrm>
+            <a:off x="4572000" y="4572000"/>
+            <a:ext cx="3291840" cy="868680"/>
+          </a:xfrm>
+          <a:prstGeom prst="rect">
+            <a:avLst/>
+          </a:prstGeom>
+          <a:noFill/>
+        </p:spPr>
+        <p:txBody>
+          <a:bodyPr wrap="square" lIns="0" rIns="0" tIns="0" bIns="0" anchor="t">
+            <a:spAutoFit/>
+          </a:bodyPr>
+          <a:lstStyle/>
+          <a:p>
+            <a:pPr algn="l"/>
+            <a:r>
               <a:rPr sz="1100" b="0" i="0">
-                <a:solidFill>
-                  <a:srgbClr val="F2C55C"/>
-                </a:solidFill>
-                <a:latin typeface="Consolas"/>
-              </a:rPr>
-              <a:t>T5 / H1 · H8</a:t>
-            </a:r>
-          </a:p>
-        </p:txBody>
-      </p:sp>
-      <p:sp>
-        <p:nvSpPr>
-          <p:cNvPr id="37" name="TextBox 36"/>
-          <p:cNvSpPr txBox="1"/>
-          <p:nvPr/>
-        </p:nvSpPr>
-        <p:spPr>
-          <a:xfrm>
-            <a:off x="4572000" y="4992624"/>
-            <a:ext cx="3291840" cy="1143000"/>
-          </a:xfrm>
-          <a:prstGeom prst="rect">
-            <a:avLst/>
-          </a:prstGeom>
-          <a:noFill/>
-        </p:spPr>
-        <p:txBody>
-          <a:bodyPr wrap="square" lIns="0" rIns="0" tIns="0" bIns="0" anchor="t">
-            <a:spAutoFit/>
-          </a:bodyPr>
-          <a:lstStyle/>
-          <a:p>
-            <a:pPr algn="l"/>
-            <a:r>
-              <a:rPr sz="1150" b="0" i="0">
                 <a:solidFill>
                   <a:srgbClr val="9FB5C9"/>
                 </a:solidFill>
@@ -32346,8 +32346,8 @@
         </p:nvSpPr>
         <p:spPr>
           <a:xfrm>
-            <a:off x="8046720" y="4078224"/>
-            <a:ext cx="3657600" cy="2103120"/>
+            <a:off x="8046720" y="3730752"/>
+            <a:ext cx="3657600" cy="1783080"/>
           </a:xfrm>
           <a:prstGeom prst="roundRect">
             <a:avLst>
@@ -32391,8 +32391,8 @@
         </p:nvSpPr>
         <p:spPr>
           <a:xfrm>
-            <a:off x="8046720" y="4078224"/>
-            <a:ext cx="128016" cy="2103120"/>
+            <a:off x="8046720" y="3730752"/>
+            <a:ext cx="128016" cy="1783080"/>
           </a:xfrm>
           <a:prstGeom prst="rect">
             <a:avLst/>
@@ -32434,8 +32434,8 @@
         </p:nvSpPr>
         <p:spPr>
           <a:xfrm>
-            <a:off x="8321040" y="4187952"/>
-            <a:ext cx="777240" cy="365760"/>
+            <a:off x="8321040" y="3822192"/>
+            <a:ext cx="777240" cy="329184"/>
           </a:xfrm>
           <a:prstGeom prst="rect">
             <a:avLst/>
@@ -32469,8 +32469,8 @@
         </p:nvSpPr>
         <p:spPr>
           <a:xfrm>
-            <a:off x="9052560" y="4197096"/>
-            <a:ext cx="2560320" cy="365760"/>
+            <a:off x="9052560" y="3831336"/>
+            <a:ext cx="2560320" cy="329184"/>
           </a:xfrm>
           <a:prstGeom prst="rect">
             <a:avLst/>
@@ -32504,8 +32504,8 @@
         </p:nvSpPr>
         <p:spPr>
           <a:xfrm>
-            <a:off x="8321040" y="4626864"/>
-            <a:ext cx="3291840" cy="365760"/>
+            <a:off x="8321040" y="4233672"/>
+            <a:ext cx="3291840" cy="292608"/>
           </a:xfrm>
           <a:prstGeom prst="rect">
             <a:avLst/>
@@ -32520,42 +32520,42 @@
           <a:p>
             <a:pPr algn="l"/>
             <a:r>
+              <a:rPr sz="1050" b="0" i="0">
+                <a:solidFill>
+                  <a:srgbClr val="F2C55C"/>
+                </a:solidFill>
+                <a:latin typeface="Consolas"/>
+              </a:rPr>
+              <a:t>T4 / H4</a:t>
+            </a:r>
+          </a:p>
+        </p:txBody>
+      </p:sp>
+      <p:sp>
+        <p:nvSpPr>
+          <p:cNvPr id="43" name="TextBox 42"/>
+          <p:cNvSpPr txBox="1"/>
+          <p:nvPr/>
+        </p:nvSpPr>
+        <p:spPr>
+          <a:xfrm>
+            <a:off x="8321040" y="4572000"/>
+            <a:ext cx="3291840" cy="868680"/>
+          </a:xfrm>
+          <a:prstGeom prst="rect">
+            <a:avLst/>
+          </a:prstGeom>
+          <a:noFill/>
+        </p:spPr>
+        <p:txBody>
+          <a:bodyPr wrap="square" lIns="0" rIns="0" tIns="0" bIns="0" anchor="t">
+            <a:spAutoFit/>
+          </a:bodyPr>
+          <a:lstStyle/>
+          <a:p>
+            <a:pPr algn="l"/>
+            <a:r>
               <a:rPr sz="1100" b="0" i="0">
-                <a:solidFill>
-                  <a:srgbClr val="F2C55C"/>
-                </a:solidFill>
-                <a:latin typeface="Consolas"/>
-              </a:rPr>
-              <a:t>T4 / H4</a:t>
-            </a:r>
-          </a:p>
-        </p:txBody>
-      </p:sp>
-      <p:sp>
-        <p:nvSpPr>
-          <p:cNvPr id="43" name="TextBox 42"/>
-          <p:cNvSpPr txBox="1"/>
-          <p:nvPr/>
-        </p:nvSpPr>
-        <p:spPr>
-          <a:xfrm>
-            <a:off x="8321040" y="4992624"/>
-            <a:ext cx="3291840" cy="1143000"/>
-          </a:xfrm>
-          <a:prstGeom prst="rect">
-            <a:avLst/>
-          </a:prstGeom>
-          <a:noFill/>
-        </p:spPr>
-        <p:txBody>
-          <a:bodyPr wrap="square" lIns="0" rIns="0" tIns="0" bIns="0" anchor="t">
-            <a:spAutoFit/>
-          </a:bodyPr>
-          <a:lstStyle/>
-          <a:p>
-            <a:pPr algn="l"/>
-            <a:r>
-              <a:rPr sz="1150" b="0" i="0">
                 <a:solidFill>
                   <a:srgbClr val="9FB5C9"/>
                 </a:solidFill>
@@ -32574,8 +32574,8 @@
         </p:nvSpPr>
         <p:spPr>
           <a:xfrm>
-            <a:off x="4297680" y="6327648"/>
-            <a:ext cx="3657600" cy="2103120"/>
+            <a:off x="548640" y="5632704"/>
+            <a:ext cx="11109960" cy="868680"/>
           </a:xfrm>
           <a:prstGeom prst="roundRect">
             <a:avLst>
@@ -32583,7 +32583,7 @@
             </a:avLst>
           </a:prstGeom>
           <a:solidFill>
-            <a:srgbClr val="122A43"/>
+            <a:srgbClr val="183553"/>
           </a:solidFill>
           <a:ln>
             <a:noFill/>
@@ -32619,8 +32619,8 @@
         </p:nvSpPr>
         <p:spPr>
           <a:xfrm>
-            <a:off x="4297680" y="6327648"/>
-            <a:ext cx="128016" cy="2103120"/>
+            <a:off x="548640" y="5632704"/>
+            <a:ext cx="128016" cy="868680"/>
           </a:xfrm>
           <a:prstGeom prst="rect">
             <a:avLst/>
@@ -32662,7 +32662,7 @@
         </p:nvSpPr>
         <p:spPr>
           <a:xfrm>
-            <a:off x="4572000" y="6437376"/>
+            <a:off x="822960" y="5751576"/>
             <a:ext cx="777240" cy="365760"/>
           </a:xfrm>
           <a:prstGeom prst="rect">
@@ -32678,7 +32678,7 @@
           <a:p>
             <a:pPr algn="l"/>
             <a:r>
-              <a:rPr sz="1600" b="1" i="0">
+              <a:rPr sz="1800" b="1" i="0">
                 <a:solidFill>
                   <a:srgbClr val="F2C55C"/>
                 </a:solidFill>
@@ -32697,8 +32697,8 @@
         </p:nvSpPr>
         <p:spPr>
           <a:xfrm>
-            <a:off x="5303520" y="6446520"/>
-            <a:ext cx="2560320" cy="365760"/>
+            <a:off x="1554480" y="5751576"/>
+            <a:ext cx="3291840" cy="365760"/>
           </a:xfrm>
           <a:prstGeom prst="rect">
             <a:avLst/>
@@ -32713,7 +32713,7 @@
           <a:p>
             <a:pPr algn="l"/>
             <a:r>
-              <a:rPr sz="1400" b="1" i="0">
+              <a:rPr sz="1500" b="1" i="0">
                 <a:solidFill>
                   <a:srgbClr val="EAF2FA"/>
                 </a:solidFill>
@@ -32732,8 +32732,43 @@
         </p:nvSpPr>
         <p:spPr>
           <a:xfrm>
-            <a:off x="4572000" y="6876288"/>
-            <a:ext cx="3291840" cy="365760"/>
+            <a:off x="4983480" y="5779008"/>
+            <a:ext cx="2103120" cy="365760"/>
+          </a:xfrm>
+          <a:prstGeom prst="rect">
+            <a:avLst/>
+          </a:prstGeom>
+          <a:noFill/>
+        </p:spPr>
+        <p:txBody>
+          <a:bodyPr wrap="square" lIns="0" rIns="0" tIns="0" bIns="0" anchor="ctr">
+            <a:spAutoFit/>
+          </a:bodyPr>
+          <a:lstStyle/>
+          <a:p>
+            <a:pPr algn="l"/>
+            <a:r>
+              <a:rPr sz="1100" b="0" i="0">
+                <a:solidFill>
+                  <a:srgbClr val="F2C55C"/>
+                </a:solidFill>
+                <a:latin typeface="Consolas"/>
+              </a:rPr>
+              <a:t>T1 · T2 / H9</a:t>
+            </a:r>
+          </a:p>
+        </p:txBody>
+      </p:sp>
+      <p:sp>
+        <p:nvSpPr>
+          <p:cNvPr id="49" name="TextBox 48"/>
+          <p:cNvSpPr txBox="1"/>
+          <p:nvPr/>
+        </p:nvSpPr>
+        <p:spPr>
+          <a:xfrm>
+            <a:off x="7223760" y="5751576"/>
+            <a:ext cx="4297680" cy="365760"/>
           </a:xfrm>
           <a:prstGeom prst="rect">
             <a:avLst/>
@@ -32748,55 +32783,55 @@
           <a:p>
             <a:pPr algn="l"/>
             <a:r>
+              <a:rPr sz="1200" b="1" i="0">
+                <a:solidFill>
+                  <a:srgbClr val="F2C55C"/>
+                </a:solidFill>
+                <a:latin typeface="Microsoft YaHei"/>
+              </a:rPr>
+              <a:t>横切的「度量层」</a:t>
+            </a:r>
+          </a:p>
+        </p:txBody>
+      </p:sp>
+      <p:sp>
+        <p:nvSpPr>
+          <p:cNvPr id="50" name="TextBox 49"/>
+          <p:cNvSpPr txBox="1"/>
+          <p:nvPr/>
+        </p:nvSpPr>
+        <p:spPr>
+          <a:xfrm>
+            <a:off x="822960" y="6135624"/>
+            <a:ext cx="10744200" cy="329184"/>
+          </a:xfrm>
+          <a:prstGeom prst="rect">
+            <a:avLst/>
+          </a:prstGeom>
+          <a:noFill/>
+        </p:spPr>
+        <p:txBody>
+          <a:bodyPr wrap="square" lIns="0" rIns="0" tIns="0" bIns="0" anchor="t">
+            <a:spAutoFit/>
+          </a:bodyPr>
+          <a:lstStyle/>
+          <a:p>
+            <a:pPr algn="l"/>
+            <a:r>
               <a:rPr sz="1100" b="0" i="0">
                 <a:solidFill>
-                  <a:srgbClr val="F2C55C"/>
-                </a:solidFill>
-                <a:latin typeface="Consolas"/>
-              </a:rPr>
-              <a:t>T1 · T2 / H9</a:t>
-            </a:r>
-          </a:p>
-        </p:txBody>
-      </p:sp>
-      <p:sp>
-        <p:nvSpPr>
-          <p:cNvPr id="49" name="TextBox 48"/>
-          <p:cNvSpPr txBox="1"/>
-          <p:nvPr/>
-        </p:nvSpPr>
-        <p:spPr>
-          <a:xfrm>
-            <a:off x="4572000" y="7242048"/>
-            <a:ext cx="3291840" cy="1143000"/>
-          </a:xfrm>
-          <a:prstGeom prst="rect">
-            <a:avLst/>
-          </a:prstGeom>
-          <a:noFill/>
-        </p:spPr>
-        <p:txBody>
-          <a:bodyPr wrap="square" lIns="0" rIns="0" tIns="0" bIns="0" anchor="t">
-            <a:spAutoFit/>
-          </a:bodyPr>
-          <a:lstStyle/>
-          <a:p>
-            <a:pPr algn="l"/>
-            <a:r>
-              <a:rPr sz="1150" b="0" i="0">
-                <a:solidFill>
                   <a:srgbClr val="9FB5C9"/>
                 </a:solidFill>
                 <a:latin typeface="Microsoft YaHei"/>
               </a:rPr>
-              <a:t>统一形状层级 / baseline / 报表 schema，跨工作可比。</a:t>
-            </a:r>
-          </a:p>
-        </p:txBody>
-      </p:sp>
-      <p:sp>
-        <p:nvSpPr>
-          <p:cNvPr id="50" name="TextBox 49"/>
+              <a:t>统一形状层级 / baseline / 报表 schema → 跨工作 / 跨硬件 / 跨版本可横向对比；是把前 6 个特征「真正落到工程」的前提。</a:t>
+            </a:r>
+          </a:p>
+        </p:txBody>
+      </p:sp>
+      <p:sp>
+        <p:nvSpPr>
+          <p:cNvPr id="51" name="TextBox 50"/>
           <p:cNvSpPr txBox="1"/>
           <p:nvPr/>
         </p:nvSpPr>
@@ -32831,7 +32866,7 @@
       </p:sp>
       <p:sp>
         <p:nvSpPr>
-          <p:cNvPr id="51" name="TextBox 50"/>
+          <p:cNvPr id="52" name="TextBox 51"/>
           <p:cNvSpPr txBox="1"/>
           <p:nvPr/>
         </p:nvSpPr>

</xml_diff>